<commit_message>
Apply cross-system audit fixes
BESTAE: t5 #E8F6C4, t8 #D2DCE8, t10 #F7D0E6 so domain tints are distinct
(t10 at 32% keeps denim links above 4.5:1). Greyscale: link #5E5E5E and a
named coding set. MBE: accent-bloom-deep #e3008c and border-strong #a48061.
Swatches, Word template, PowerPoint copy, greyscale skill copy and repo
copies of the design systems updated; audit and handoff marked.

Co-Authored-By: Claude Opus 5.5 <noreply@anthropic.com>
Claude-Session: https://claude.ai/code/session_01QCmM6DGQPCkNA2jgkdPRkH
</commit_message>
<xml_diff>
--- a/brand/bestae/updated-files/Bestae Template (updated palette).pptx
+++ b/brand/bestae/updated-files/Bestae Template (updated palette).pptx
@@ -4047,7 +4047,7 @@
                 <a:ea typeface="Times New Roman" panose="02020603050405020304" pitchFamily="18" charset="0"/>
                 <a:cs typeface="Times New Roman" panose="02020603050405020304" pitchFamily="18" charset="0"/>
               </a:rPr>
-              <a:t>: #EFF4A4; }</a:t>
+              <a:t>: #E8F6C4; }</a:t>
             </a:r>
             <a:endParaRPr lang="en-AU" sz="1800" dirty="0">
               <a:effectLst/>
@@ -4161,7 +4161,7 @@
                 <a:ea typeface="Times New Roman" panose="02020603050405020304" pitchFamily="18" charset="0"/>
                 <a:cs typeface="Times New Roman" panose="02020603050405020304" pitchFamily="18" charset="0"/>
               </a:rPr>
-              <a:t>: #D5EBEE; }</a:t>
+              <a:t>: #D2DCE8; }</a:t>
             </a:r>
             <a:endParaRPr lang="en-AU" sz="1800" dirty="0">
               <a:effectLst/>
@@ -4237,7 +4237,7 @@
                 <a:ea typeface="Times New Roman" panose="02020603050405020304" pitchFamily="18" charset="0"/>
                 <a:cs typeface="Times New Roman" panose="02020603050405020304" pitchFamily="18" charset="0"/>
               </a:rPr>
-              <a:t>: #F2DEE9; }</a:t>
+              <a:t>: #F7D0E6; }</a:t>
             </a:r>
             <a:endParaRPr lang="en-AU" sz="1800" dirty="0">
               <a:effectLst/>

</xml_diff>